<commit_message>
Update 물병 세우기 assets and add ZIP slides
Co-Authored-By: Claude Opus 4.6 (1M context) <noreply@anthropic.com>
</commit_message>
<xml_diff>
--- a/public/downloads/games/bottle-flip/rules.pptx
+++ b/public/downloads/games/bottle-flip/rules.pptx
@@ -15,16 +15,12 @@
   <p:notesSz cx="6858000" cy="9144000"/>
   <p:embeddedFontLst>
     <p:embeddedFont>
-      <p:font typeface="Jua" charset="1" panose="00000000000000000000"/>
+      <p:font typeface="무궁화 고딕" charset="1" panose="02020603020101020101"/>
       <p:regular r:id="rId11"/>
     </p:embeddedFont>
     <p:embeddedFont>
-      <p:font typeface="TDTD갬성명조" charset="1" panose="02000503000000000000"/>
+      <p:font typeface="무궁화 고딕 Bold" charset="1" panose="02020603020101020101"/>
       <p:regular r:id="rId12"/>
-    </p:embeddedFont>
-    <p:embeddedFont>
-      <p:font typeface="TDTD가온" charset="1" panose="02000503000000000000"/>
-      <p:regular r:id="rId13"/>
     </p:embeddedFont>
   </p:embeddedFontLst>
   <p:defaultTextStyle>
@@ -3142,8 +3138,8 @@
         </p:nvSpPr>
         <p:spPr>
           <a:xfrm rot="0">
-            <a:off x="1028700" y="3892867"/>
-            <a:ext cx="15555091" cy="2200275"/>
+            <a:off x="1028700" y="4178617"/>
+            <a:ext cx="15555091" cy="1914525"/>
           </a:xfrm>
           <a:prstGeom prst="rect">
             <a:avLst/>
@@ -3165,10 +3161,10 @@
                 <a:solidFill>
                   <a:srgbClr val="FFFAEF"/>
                 </a:solidFill>
-                <a:latin typeface="Jua"/>
-                <a:ea typeface="Jua"/>
-                <a:cs typeface="Jua"/>
-                <a:sym typeface="Jua"/>
+                <a:latin typeface="무궁화 고딕"/>
+                <a:ea typeface="무궁화 고딕"/>
+                <a:cs typeface="무궁화 고딕"/>
+                <a:sym typeface="무궁화 고딕"/>
               </a:rPr>
               <a:t>물병 세우기</a:t>
             </a:r>
@@ -3183,8 +3179,8 @@
         </p:nvSpPr>
         <p:spPr>
           <a:xfrm rot="0">
-            <a:off x="15264803" y="9812655"/>
-            <a:ext cx="2637975" cy="474345"/>
+            <a:off x="14222066" y="9822180"/>
+            <a:ext cx="3680712" cy="464820"/>
           </a:xfrm>
           <a:prstGeom prst="rect">
             <a:avLst/>
@@ -3209,10 +3205,10 @@
                 <a:solidFill>
                   <a:srgbClr val="FFFFFF"/>
                 </a:solidFill>
-                <a:latin typeface="TDTD갬성명조"/>
-                <a:ea typeface="TDTD갬성명조"/>
-                <a:cs typeface="TDTD갬성명조"/>
-                <a:sym typeface="TDTD갬성명조"/>
+                <a:latin typeface="무궁화 고딕"/>
+                <a:ea typeface="무궁화 고딕"/>
+                <a:cs typeface="무궁화 고딕"/>
+                <a:sym typeface="무궁화 고딕"/>
               </a:rPr>
               <a:t>ⓒ 2026. Sunday Play</a:t>
             </a:r>
@@ -3361,8 +3357,8 @@
         </p:nvSpPr>
         <p:spPr>
           <a:xfrm rot="0">
-            <a:off x="11392761" y="600705"/>
-            <a:ext cx="5362043" cy="1600200"/>
+            <a:off x="11392761" y="819780"/>
+            <a:ext cx="5362043" cy="1381125"/>
           </a:xfrm>
           <a:prstGeom prst="rect">
             <a:avLst/>
@@ -3384,10 +3380,10 @@
                 <a:solidFill>
                   <a:srgbClr val="FFFAEF"/>
                 </a:solidFill>
-                <a:latin typeface="Jua"/>
-                <a:ea typeface="Jua"/>
-                <a:cs typeface="Jua"/>
-                <a:sym typeface="Jua"/>
+                <a:latin typeface="무궁화 고딕"/>
+                <a:ea typeface="무궁화 고딕"/>
+                <a:cs typeface="무궁화 고딕"/>
+                <a:sym typeface="무궁화 고딕"/>
               </a:rPr>
               <a:t>규칙</a:t>
             </a:r>
@@ -3403,9 +3399,9 @@
         <p:grpSpPr>
           <a:xfrm rot="0">
             <a:off x="309172" y="535073"/>
-            <a:ext cx="8625065" cy="3171514"/>
+            <a:ext cx="8625065" cy="2412054"/>
             <a:chOff x="0" y="0"/>
-            <a:chExt cx="11500087" cy="4228686"/>
+            <a:chExt cx="11500087" cy="3216072"/>
           </a:xfrm>
         </p:grpSpPr>
         <p:sp>
@@ -3416,8 +3412,8 @@
           </p:nvSpPr>
           <p:spPr>
             <a:xfrm rot="0">
-              <a:off x="0" y="1386214"/>
-              <a:ext cx="11500087" cy="2842472"/>
+              <a:off x="0" y="1395739"/>
+              <a:ext cx="11500087" cy="1820333"/>
             </a:xfrm>
             <a:prstGeom prst="rect">
               <a:avLst/>
@@ -3431,28 +3427,21 @@
             <a:p>
               <a:pPr algn="l">
                 <a:lnSpc>
-                  <a:spcPts val="5739"/>
+                  <a:spcPts val="5599"/>
                 </a:lnSpc>
               </a:pPr>
               <a:r>
-                <a:rPr lang="en-US" sz="4099">
+                <a:rPr lang="en-US" sz="3999">
                   <a:solidFill>
                     <a:srgbClr val="FFFAEF"/>
                   </a:solidFill>
-                  <a:latin typeface="TDTD가온"/>
-                  <a:ea typeface="TDTD가온"/>
-                  <a:cs typeface="TDTD가온"/>
-                  <a:sym typeface="TDTD가온"/>
+                  <a:latin typeface="무궁화 고딕"/>
+                  <a:ea typeface="무궁화 고딕"/>
+                  <a:cs typeface="무궁화 고딕"/>
+                  <a:sym typeface="무궁화 고딕"/>
                 </a:rPr>
                 <a:t>팀을 나누고, 각 팀에 물이 ⅓ 들어있는 500ml 물병을 1개씩 배분합니다. </a:t>
               </a:r>
-            </a:p>
-            <a:p>
-              <a:pPr algn="l">
-                <a:lnSpc>
-                  <a:spcPts val="5739"/>
-                </a:lnSpc>
-              </a:pPr>
             </a:p>
           </p:txBody>
         </p:sp>
@@ -3464,8 +3453,8 @@
           </p:nvSpPr>
           <p:spPr>
             <a:xfrm rot="0">
-              <a:off x="0" y="-161925"/>
-              <a:ext cx="10684245" cy="1111038"/>
+              <a:off x="0" y="-57150"/>
+              <a:ext cx="10684245" cy="1006263"/>
             </a:xfrm>
             <a:prstGeom prst="rect">
               <a:avLst/>
@@ -3487,10 +3476,10 @@
                   <a:solidFill>
                     <a:srgbClr val="FFFAEF"/>
                   </a:solidFill>
-                  <a:latin typeface="Jua"/>
-                  <a:ea typeface="Jua"/>
-                  <a:cs typeface="Jua"/>
-                  <a:sym typeface="Jua"/>
+                  <a:latin typeface="무궁화 고딕 Bold"/>
+                  <a:ea typeface="무궁화 고딕 Bold"/>
+                  <a:cs typeface="무궁화 고딕 Bold"/>
+                  <a:sym typeface="무궁화 고딕 Bold"/>
                 </a:rPr>
                 <a:t>STEP 1.</a:t>
               </a:r>
@@ -3506,10 +3495,10 @@
         </p:nvGrpSpPr>
         <p:grpSpPr>
           <a:xfrm rot="0">
-            <a:off x="9797745" y="7419270"/>
-            <a:ext cx="8552074" cy="3166651"/>
+            <a:off x="9334874" y="7539586"/>
+            <a:ext cx="8953126" cy="2371631"/>
             <a:chOff x="0" y="0"/>
-            <a:chExt cx="11402765" cy="4222201"/>
+            <a:chExt cx="11937502" cy="3162174"/>
           </a:xfrm>
         </p:grpSpPr>
         <p:sp>
@@ -3521,7 +3510,7 @@
           <p:spPr>
             <a:xfrm rot="0">
               <a:off x="0" y="1379728"/>
-              <a:ext cx="11402765" cy="2842473"/>
+              <a:ext cx="11937502" cy="1782446"/>
             </a:xfrm>
             <a:prstGeom prst="rect">
               <a:avLst/>
@@ -3535,30 +3524,30 @@
             <a:p>
               <a:pPr algn="l">
                 <a:lnSpc>
-                  <a:spcPts val="5739"/>
+                  <a:spcPts val="5459"/>
                 </a:lnSpc>
               </a:pPr>
               <a:r>
-                <a:rPr lang="en-US" sz="4099">
+                <a:rPr lang="en-US" sz="3899">
                   <a:solidFill>
                     <a:srgbClr val="FFFAEF"/>
                   </a:solidFill>
-                  <a:latin typeface="TDTD가온"/>
-                  <a:ea typeface="TDTD가온"/>
-                  <a:cs typeface="TDTD가온"/>
-                  <a:sym typeface="TDTD가온"/>
+                  <a:latin typeface="무궁화 고딕"/>
+                  <a:ea typeface="무궁화 고딕"/>
+                  <a:cs typeface="무궁화 고딕"/>
+                  <a:sym typeface="무궁화 고딕"/>
                 </a:rPr>
                 <a:t>전원이</a:t>
               </a:r>
               <a:r>
-                <a:rPr lang="en-US" sz="4099">
+                <a:rPr lang="en-US" sz="3899">
                   <a:solidFill>
                     <a:srgbClr val="FFFAEF"/>
                   </a:solidFill>
-                  <a:latin typeface="TDTD가온"/>
-                  <a:ea typeface="TDTD가온"/>
-                  <a:cs typeface="TDTD가온"/>
-                  <a:sym typeface="TDTD가온"/>
+                  <a:latin typeface="무궁화 고딕"/>
+                  <a:ea typeface="무궁화 고딕"/>
+                  <a:cs typeface="무궁화 고딕"/>
+                  <a:sym typeface="무궁화 고딕"/>
                 </a:rPr>
                 <a:t> 한 번씩 도전하면 1라운드 종료.                                                  </a:t>
               </a:r>
@@ -3566,28 +3555,21 @@
             <a:p>
               <a:pPr algn="l">
                 <a:lnSpc>
-                  <a:spcPts val="5739"/>
+                  <a:spcPts val="5459"/>
                 </a:lnSpc>
               </a:pPr>
               <a:r>
-                <a:rPr lang="en-US" sz="4099">
+                <a:rPr lang="en-US" sz="3899">
                   <a:solidFill>
                     <a:srgbClr val="FFFAEF"/>
                   </a:solidFill>
-                  <a:latin typeface="TDTD가온"/>
-                  <a:ea typeface="TDTD가온"/>
-                  <a:cs typeface="TDTD가온"/>
-                  <a:sym typeface="TDTD가온"/>
+                  <a:latin typeface="무궁화 고딕"/>
+                  <a:ea typeface="무궁화 고딕"/>
+                  <a:cs typeface="무궁화 고딕"/>
+                  <a:sym typeface="무궁화 고딕"/>
                 </a:rPr>
-                <a:t> 3라운드 반복 후 누적 점수가 높은 팀이 우승!</a:t>
+                <a:t>3라운드 반복 후 누적 점수가 높은 팀이 우승!</a:t>
               </a:r>
-            </a:p>
-            <a:p>
-              <a:pPr algn="l">
-                <a:lnSpc>
-                  <a:spcPts val="5739"/>
-                </a:lnSpc>
-              </a:pPr>
             </a:p>
           </p:txBody>
         </p:sp>
@@ -3599,8 +3581,8 @@
           </p:nvSpPr>
           <p:spPr>
             <a:xfrm rot="0">
-              <a:off x="0" y="-161925"/>
-              <a:ext cx="11402765" cy="1111039"/>
+              <a:off x="0" y="-57150"/>
+              <a:ext cx="11937502" cy="1006264"/>
             </a:xfrm>
             <a:prstGeom prst="rect">
               <a:avLst/>
@@ -3622,10 +3604,10 @@
                   <a:solidFill>
                     <a:srgbClr val="FFFAEF"/>
                   </a:solidFill>
-                  <a:latin typeface="Jua"/>
-                  <a:ea typeface="Jua"/>
-                  <a:cs typeface="Jua"/>
-                  <a:sym typeface="Jua"/>
+                  <a:latin typeface="무궁화 고딕 Bold"/>
+                  <a:ea typeface="무궁화 고딕 Bold"/>
+                  <a:cs typeface="무궁화 고딕 Bold"/>
+                  <a:sym typeface="무궁화 고딕 Bold"/>
                 </a:rPr>
                 <a:t>STEP 3.</a:t>
               </a:r>
@@ -3641,10 +3623,10 @@
         </p:nvGrpSpPr>
         <p:grpSpPr>
           <a:xfrm rot="0">
-            <a:off x="3700752" y="3939905"/>
-            <a:ext cx="10466970" cy="2442750"/>
+            <a:off x="3700752" y="4039761"/>
+            <a:ext cx="10466970" cy="2407190"/>
             <a:chOff x="0" y="0"/>
-            <a:chExt cx="13955960" cy="3257001"/>
+            <a:chExt cx="13955960" cy="3209587"/>
           </a:xfrm>
         </p:grpSpPr>
         <p:sp>
@@ -3655,8 +3637,8 @@
           </p:nvSpPr>
           <p:spPr>
             <a:xfrm rot="0">
-              <a:off x="0" y="1379728"/>
-              <a:ext cx="13955960" cy="1877273"/>
+              <a:off x="0" y="1389253"/>
+              <a:ext cx="13955960" cy="1820334"/>
             </a:xfrm>
             <a:prstGeom prst="rect">
               <a:avLst/>
@@ -3670,51 +3652,32 @@
             <a:p>
               <a:pPr algn="l">
                 <a:lnSpc>
-                  <a:spcPts val="5739"/>
+                  <a:spcPts val="5599"/>
                 </a:lnSpc>
               </a:pPr>
               <a:r>
-                <a:rPr lang="en-US" sz="4099">
+                <a:rPr lang="en-US" sz="3999">
                   <a:solidFill>
                     <a:srgbClr val="FFFAEF"/>
                   </a:solidFill>
-                  <a:latin typeface="TDTD가온"/>
-                  <a:ea typeface="TDTD가온"/>
-                  <a:cs typeface="TDTD가온"/>
-                  <a:sym typeface="TDTD가온"/>
+                  <a:latin typeface="무궁화 고딕"/>
+                  <a:ea typeface="무궁화 고딕"/>
+                  <a:cs typeface="무궁화 고딕"/>
+                  <a:sym typeface="무궁화 고딕"/>
                 </a:rPr>
                 <a:t>팀원</a:t>
               </a:r>
               <a:r>
-                <a:rPr lang="en-US" sz="4099">
+                <a:rPr lang="en-US" sz="3999">
                   <a:solidFill>
                     <a:srgbClr val="FFFAEF"/>
                   </a:solidFill>
-                  <a:latin typeface="TDTD가온"/>
-                  <a:ea typeface="TDTD가온"/>
-                  <a:cs typeface="TDTD가온"/>
-                  <a:sym typeface="TDTD가온"/>
+                  <a:latin typeface="무궁화 고딕"/>
+                  <a:ea typeface="무궁화 고딕"/>
+                  <a:cs typeface="무궁화 고딕"/>
+                  <a:sym typeface="무궁화 고딕"/>
                 </a:rPr>
-                <a:t>이 차례대로 나와 물병을 한 바퀴 돌려 던집니다.                                           </a:t>
-              </a:r>
-            </a:p>
-            <a:p>
-              <a:pPr algn="l">
-                <a:lnSpc>
-                  <a:spcPts val="5739"/>
-                </a:lnSpc>
-              </a:pPr>
-              <a:r>
-                <a:rPr lang="en-US" sz="4099">
-                  <a:solidFill>
-                    <a:srgbClr val="FFFAEF"/>
-                  </a:solidFill>
-                  <a:latin typeface="TDTD가온"/>
-                  <a:ea typeface="TDTD가온"/>
-                  <a:cs typeface="TDTD가온"/>
-                  <a:sym typeface="TDTD가온"/>
-                </a:rPr>
-                <a:t> 물병이 바닥에 똑바로 서면 1점! </a:t>
+                <a:t>이 차례대로 나와 물병을 한 바퀴 돌려 던집니다. 물병이 바닥에 똑바로 서면 1점! </a:t>
               </a:r>
             </a:p>
           </p:txBody>
@@ -3727,8 +3690,8 @@
           </p:nvSpPr>
           <p:spPr>
             <a:xfrm rot="0">
-              <a:off x="0" y="-161925"/>
-              <a:ext cx="10551700" cy="1111038"/>
+              <a:off x="0" y="-57150"/>
+              <a:ext cx="10551700" cy="1006263"/>
             </a:xfrm>
             <a:prstGeom prst="rect">
               <a:avLst/>
@@ -3750,10 +3713,10 @@
                   <a:solidFill>
                     <a:srgbClr val="FFFAEF"/>
                   </a:solidFill>
-                  <a:latin typeface="Jua"/>
-                  <a:ea typeface="Jua"/>
-                  <a:cs typeface="Jua"/>
-                  <a:sym typeface="Jua"/>
+                  <a:latin typeface="무궁화 고딕 Bold"/>
+                  <a:ea typeface="무궁화 고딕 Bold"/>
+                  <a:cs typeface="무궁화 고딕 Bold"/>
+                  <a:sym typeface="무궁화 고딕 Bold"/>
                 </a:rPr>
                 <a:t>STEP 2.</a:t>
               </a:r>
@@ -3801,8 +3764,8 @@
         </p:nvSpPr>
         <p:spPr>
           <a:xfrm rot="0">
-            <a:off x="3238925" y="4092795"/>
-            <a:ext cx="11810151" cy="2200275"/>
+            <a:off x="3238925" y="4378545"/>
+            <a:ext cx="11810151" cy="1914525"/>
           </a:xfrm>
           <a:prstGeom prst="rect">
             <a:avLst/>
@@ -3824,10 +3787,10 @@
                 <a:solidFill>
                   <a:srgbClr val="000000"/>
                 </a:solidFill>
-                <a:latin typeface="Jua"/>
-                <a:ea typeface="Jua"/>
-                <a:cs typeface="Jua"/>
-                <a:sym typeface="Jua"/>
+                <a:latin typeface="무궁화 고딕"/>
+                <a:ea typeface="무궁화 고딕"/>
+                <a:cs typeface="무궁화 고딕"/>
+                <a:sym typeface="무궁화 고딕"/>
               </a:rPr>
               <a:t>팀을 나눠주세요!</a:t>
             </a:r>
@@ -3974,8 +3937,8 @@
         </p:nvSpPr>
         <p:spPr>
           <a:xfrm rot="0">
-            <a:off x="1028700" y="3892867"/>
-            <a:ext cx="15555091" cy="2200275"/>
+            <a:off x="1028700" y="4178617"/>
+            <a:ext cx="15555091" cy="1914525"/>
           </a:xfrm>
           <a:prstGeom prst="rect">
             <a:avLst/>
@@ -3997,10 +3960,10 @@
                 <a:solidFill>
                   <a:srgbClr val="FFFAEF"/>
                 </a:solidFill>
-                <a:latin typeface="Jua"/>
-                <a:ea typeface="Jua"/>
-                <a:cs typeface="Jua"/>
-                <a:sym typeface="Jua"/>
+                <a:latin typeface="무궁화 고딕"/>
+                <a:ea typeface="무궁화 고딕"/>
+                <a:cs typeface="무궁화 고딕"/>
+                <a:sym typeface="무궁화 고딕"/>
               </a:rPr>
               <a:t>물병 세우기</a:t>
             </a:r>
@@ -4015,8 +3978,8 @@
         </p:nvSpPr>
         <p:spPr>
           <a:xfrm rot="0">
-            <a:off x="15264803" y="9812655"/>
-            <a:ext cx="2637975" cy="474345"/>
+            <a:off x="14222066" y="9822180"/>
+            <a:ext cx="3680712" cy="464820"/>
           </a:xfrm>
           <a:prstGeom prst="rect">
             <a:avLst/>
@@ -4041,10 +4004,10 @@
                 <a:solidFill>
                   <a:srgbClr val="FFFFFF"/>
                 </a:solidFill>
-                <a:latin typeface="TDTD갬성명조"/>
-                <a:ea typeface="TDTD갬성명조"/>
-                <a:cs typeface="TDTD갬성명조"/>
-                <a:sym typeface="TDTD갬성명조"/>
+                <a:latin typeface="무궁화 고딕"/>
+                <a:ea typeface="무궁화 고딕"/>
+                <a:cs typeface="무궁화 고딕"/>
+                <a:sym typeface="무궁화 고딕"/>
               </a:rPr>
               <a:t>ⓒ 2026. Sunday Play</a:t>
             </a:r>
@@ -4116,8 +4079,8 @@
         </p:nvSpPr>
         <p:spPr>
           <a:xfrm rot="0">
-            <a:off x="4421807" y="3895725"/>
-            <a:ext cx="9444385" cy="2200275"/>
+            <a:off x="4421807" y="4181475"/>
+            <a:ext cx="9444385" cy="1914525"/>
           </a:xfrm>
           <a:prstGeom prst="rect">
             <a:avLst/>
@@ -4139,10 +4102,10 @@
                 <a:solidFill>
                   <a:srgbClr val="000000"/>
                 </a:solidFill>
-                <a:latin typeface="Jua"/>
-                <a:ea typeface="Jua"/>
-                <a:cs typeface="Jua"/>
-                <a:sym typeface="Jua"/>
+                <a:latin typeface="무궁화 고딕"/>
+                <a:ea typeface="무궁화 고딕"/>
+                <a:cs typeface="무궁화 고딕"/>
+                <a:sym typeface="무궁화 고딕"/>
               </a:rPr>
               <a:t>감사합니다!</a:t>
             </a:r>

</xml_diff>